<commit_message>
S6: render h1/h2/h3 equations natively via matplotlib mathtext
Replaces the plaintext Courier formula blocks with properly
typeset math images embedded in each heuristic panel:

  h1  Liquidity:  h_1 = λ_liq (1 − clamp((log_10 r + 1)/2)),
                  r = (V_24h/86400) · T_rem / Q
  h2  Slippage:   h_2 = λ_slip max(0, s_bps − θ),
                  s_bps = (VWAP(Q) − P_mid)/P_mid · 10^4
  h3  Chain+Venue: h_3 = λ_chain (t_min/T_rem) + λ_exch (1 − s(n))

Equations match Section 4 of the CAIAC paper. Added a small
disclosure line on the slide noting that h3 here corresponds to
h4 in the paper (paper's h3 is the multi-start search strategy).

Panel layout reflowed: title (h_i, name) → equation image →
one-line sub-description → italic audience question.

Co-authored-by: Cursor <cursoragent@cursor.com>
</commit_message>
<xml_diff>
--- a/docs/latex/StablecoinArbitrage_GSS2026/presentation/slides_final.pptx
+++ b/docs/latex/StablecoinArbitrage_GSS2026/presentation/slides_final.pptx
@@ -6302,7 +6302,7 @@
         <p:spPr>
           <a:xfrm>
             <a:off x="347472" y="685800"/>
-            <a:ext cx="11496751" cy="457200"/>
+            <a:ext cx="11496751" cy="365760"/>
           </a:xfrm>
           <a:prstGeom prst="rect">
             <a:avLst/>
@@ -6317,7 +6317,7 @@
           <a:p>
             <a:pPr algn="ctr"/>
             <a:r>
-              <a:rPr sz="1500" b="0" i="1">
+              <a:rPr sz="1400" b="0" i="1">
                 <a:solidFill>
                   <a:srgbClr val="1A1A2E"/>
                 </a:solidFill>
@@ -6336,7 +6336,7 @@
         </p:nvSpPr>
         <p:spPr>
           <a:xfrm>
-            <a:off x="347472" y="1188720"/>
+            <a:off x="347472" y="1143000"/>
             <a:ext cx="11496751" cy="22860"/>
           </a:xfrm>
           <a:prstGeom prst="rect">
@@ -6379,8 +6379,8 @@
         </p:nvSpPr>
         <p:spPr>
           <a:xfrm>
-            <a:off x="347472" y="1298448"/>
-            <a:ext cx="2286000" cy="3657600"/>
+            <a:off x="347472" y="1234440"/>
+            <a:ext cx="2286000" cy="3840480"/>
           </a:xfrm>
           <a:prstGeom prst="rect">
             <a:avLst/>
@@ -6422,8 +6422,8 @@
         </p:nvSpPr>
         <p:spPr>
           <a:xfrm>
-            <a:off x="438912" y="1389888"/>
-            <a:ext cx="2103120" cy="594360"/>
+            <a:off x="438912" y="1325880"/>
+            <a:ext cx="2103120" cy="548640"/>
           </a:xfrm>
           <a:prstGeom prst="rect">
             <a:avLst/>
@@ -6438,7 +6438,7 @@
           <a:p>
             <a:pPr algn="ctr"/>
             <a:r>
-              <a:rPr sz="2800" b="1" i="0">
+              <a:rPr sz="2600" b="1" i="0">
                 <a:solidFill>
                   <a:srgbClr val="FFFFFF"/>
                 </a:solidFill>
@@ -6457,8 +6457,8 @@
         </p:nvSpPr>
         <p:spPr>
           <a:xfrm>
-            <a:off x="438912" y="1984248"/>
-            <a:ext cx="2103120" cy="411480"/>
+            <a:off x="438912" y="1892808"/>
+            <a:ext cx="2103120" cy="365760"/>
           </a:xfrm>
           <a:prstGeom prst="rect">
             <a:avLst/>
@@ -6473,500 +6473,20 @@
           <a:p>
             <a:pPr algn="ctr"/>
             <a:r>
-              <a:rPr sz="1700" b="1" i="0">
+              <a:rPr sz="1600" b="1" i="0">
                 <a:solidFill>
                   <a:srgbClr val="FFFFFF"/>
                 </a:solidFill>
                 <a:latin typeface="Arial"/>
               </a:rPr>
               <a:t>Liquidity</a:t>
-            </a:r>
-          </a:p>
-        </p:txBody>
-      </p:sp>
-      <p:sp>
-        <p:nvSpPr>
-          <p:cNvPr id="10" name="TextBox 9"/>
-          <p:cNvSpPr txBox="1"/>
-          <p:nvPr/>
-        </p:nvSpPr>
-        <p:spPr>
-          <a:xfrm>
-            <a:off x="438912" y="2414016"/>
-            <a:ext cx="2103120" cy="1188720"/>
-          </a:xfrm>
-          <a:prstGeom prst="rect">
-            <a:avLst/>
-          </a:prstGeom>
-          <a:noFill/>
-        </p:spPr>
-        <p:txBody>
-          <a:bodyPr wrap="square">
-            <a:spAutoFit/>
-          </a:bodyPr>
-          <a:lstStyle/>
-          <a:p>
-            <a:pPr algn="ctr"/>
-            <a:r>
-              <a:rPr sz="1200" b="0" i="0">
-                <a:solidFill>
-                  <a:srgbClr val="FFFFFF"/>
-                </a:solidFill>
-                <a:latin typeface="Courier New"/>
-              </a:rPr>
-              <a:t>Live L2 book depth
-penalty — too thin
-to absorb order size</a:t>
-            </a:r>
-          </a:p>
-        </p:txBody>
-      </p:sp>
-      <p:sp>
-        <p:nvSpPr>
-          <p:cNvPr id="11" name="TextBox 10"/>
-          <p:cNvSpPr txBox="1"/>
-          <p:nvPr/>
-        </p:nvSpPr>
-        <p:spPr>
-          <a:xfrm>
-            <a:off x="438912" y="3767328"/>
-            <a:ext cx="2103120" cy="777240"/>
-          </a:xfrm>
-          <a:prstGeom prst="rect">
-            <a:avLst/>
-          </a:prstGeom>
-          <a:noFill/>
-        </p:spPr>
-        <p:txBody>
-          <a:bodyPr wrap="square">
-            <a:spAutoFit/>
-          </a:bodyPr>
-          <a:lstStyle/>
-          <a:p>
-            <a:pPr algn="ctr"/>
-            <a:r>
-              <a:rPr sz="1300" b="0" i="1">
-                <a:solidFill>
-                  <a:srgbClr val="FFFFAA"/>
-                </a:solidFill>
-                <a:latin typeface="Arial"/>
-              </a:rPr>
-              <a:t>"Can the book
-absorb our size?"</a:t>
-            </a:r>
-          </a:p>
-        </p:txBody>
-      </p:sp>
-      <p:sp>
-        <p:nvSpPr>
-          <p:cNvPr id="12" name="Rectangle 11"/>
-          <p:cNvSpPr/>
-          <p:nvPr/>
-        </p:nvSpPr>
-        <p:spPr>
-          <a:xfrm>
-            <a:off x="2816352" y="1298448"/>
-            <a:ext cx="2286000" cy="3657600"/>
-          </a:xfrm>
-          <a:prstGeom prst="rect">
-            <a:avLst/>
-          </a:prstGeom>
-          <a:solidFill>
-            <a:srgbClr val="CC0633"/>
-          </a:solidFill>
-          <a:ln>
-            <a:noFill/>
-          </a:ln>
-        </p:spPr>
-        <p:style>
-          <a:lnRef idx="1">
-            <a:schemeClr val="accent1"/>
-          </a:lnRef>
-          <a:fillRef idx="3">
-            <a:schemeClr val="accent1"/>
-          </a:fillRef>
-          <a:effectRef idx="2">
-            <a:schemeClr val="accent1"/>
-          </a:effectRef>
-          <a:fontRef idx="minor">
-            <a:schemeClr val="lt1"/>
-          </a:fontRef>
-        </p:style>
-        <p:txBody>
-          <a:bodyPr rtlCol="0" anchor="ctr"/>
-          <a:lstStyle/>
-          <a:p>
-            <a:pPr algn="ctr"/>
-          </a:p>
-        </p:txBody>
-      </p:sp>
-      <p:sp>
-        <p:nvSpPr>
-          <p:cNvPr id="13" name="TextBox 12"/>
-          <p:cNvSpPr txBox="1"/>
-          <p:nvPr/>
-        </p:nvSpPr>
-        <p:spPr>
-          <a:xfrm>
-            <a:off x="2907792" y="1389888"/>
-            <a:ext cx="2103120" cy="594360"/>
-          </a:xfrm>
-          <a:prstGeom prst="rect">
-            <a:avLst/>
-          </a:prstGeom>
-          <a:noFill/>
-        </p:spPr>
-        <p:txBody>
-          <a:bodyPr wrap="square">
-            <a:spAutoFit/>
-          </a:bodyPr>
-          <a:lstStyle/>
-          <a:p>
-            <a:pPr algn="ctr"/>
-            <a:r>
-              <a:rPr sz="2800" b="1" i="0">
-                <a:solidFill>
-                  <a:srgbClr val="FFFFFF"/>
-                </a:solidFill>
-                <a:latin typeface="Arial"/>
-              </a:rPr>
-              <a:t>h₂ ★</a:t>
-            </a:r>
-          </a:p>
-        </p:txBody>
-      </p:sp>
-      <p:sp>
-        <p:nvSpPr>
-          <p:cNvPr id="14" name="TextBox 13"/>
-          <p:cNvSpPr txBox="1"/>
-          <p:nvPr/>
-        </p:nvSpPr>
-        <p:spPr>
-          <a:xfrm>
-            <a:off x="2907792" y="1984248"/>
-            <a:ext cx="2103120" cy="411480"/>
-          </a:xfrm>
-          <a:prstGeom prst="rect">
-            <a:avLst/>
-          </a:prstGeom>
-          <a:noFill/>
-        </p:spPr>
-        <p:txBody>
-          <a:bodyPr wrap="square">
-            <a:spAutoFit/>
-          </a:bodyPr>
-          <a:lstStyle/>
-          <a:p>
-            <a:pPr algn="ctr"/>
-            <a:r>
-              <a:rPr sz="1700" b="1" i="0">
-                <a:solidFill>
-                  <a:srgbClr val="FFFFFF"/>
-                </a:solidFill>
-                <a:latin typeface="Arial"/>
-              </a:rPr>
-              <a:t>Slippage</a:t>
-            </a:r>
-          </a:p>
-        </p:txBody>
-      </p:sp>
-      <p:sp>
-        <p:nvSpPr>
-          <p:cNvPr id="15" name="TextBox 14"/>
-          <p:cNvSpPr txBox="1"/>
-          <p:nvPr/>
-        </p:nvSpPr>
-        <p:spPr>
-          <a:xfrm>
-            <a:off x="2907792" y="2414016"/>
-            <a:ext cx="2103120" cy="1188720"/>
-          </a:xfrm>
-          <a:prstGeom prst="rect">
-            <a:avLst/>
-          </a:prstGeom>
-          <a:noFill/>
-        </p:spPr>
-        <p:txBody>
-          <a:bodyPr wrap="square">
-            <a:spAutoFit/>
-          </a:bodyPr>
-          <a:lstStyle/>
-          <a:p>
-            <a:pPr algn="ctr"/>
-            <a:r>
-              <a:rPr sz="1200" b="0" i="0">
-                <a:solidFill>
-                  <a:srgbClr val="FFFFFF"/>
-                </a:solidFill>
-                <a:latin typeface="Courier New"/>
-              </a:rPr>
-              <a:t>VWAP penalty:
-pen = max(0, VWAP−mid)
-× order size</a:t>
-            </a:r>
-          </a:p>
-        </p:txBody>
-      </p:sp>
-      <p:sp>
-        <p:nvSpPr>
-          <p:cNvPr id="16" name="TextBox 15"/>
-          <p:cNvSpPr txBox="1"/>
-          <p:nvPr/>
-        </p:nvSpPr>
-        <p:spPr>
-          <a:xfrm>
-            <a:off x="2907792" y="3767328"/>
-            <a:ext cx="2103120" cy="777240"/>
-          </a:xfrm>
-          <a:prstGeom prst="rect">
-            <a:avLst/>
-          </a:prstGeom>
-          <a:noFill/>
-        </p:spPr>
-        <p:txBody>
-          <a:bodyPr wrap="square">
-            <a:spAutoFit/>
-          </a:bodyPr>
-          <a:lstStyle/>
-          <a:p>
-            <a:pPr algn="ctr"/>
-            <a:r>
-              <a:rPr sz="1300" b="0" i="1">
-                <a:solidFill>
-                  <a:srgbClr val="FFFFAA"/>
-                </a:solidFill>
-                <a:latin typeface="Arial"/>
-              </a:rPr>
-              <a:t>"Will my order
-move the price?"</a:t>
-            </a:r>
-          </a:p>
-        </p:txBody>
-      </p:sp>
-      <p:sp>
-        <p:nvSpPr>
-          <p:cNvPr id="17" name="Rectangle 16"/>
-          <p:cNvSpPr/>
-          <p:nvPr/>
-        </p:nvSpPr>
-        <p:spPr>
-          <a:xfrm>
-            <a:off x="5285232" y="1298448"/>
-            <a:ext cx="2286000" cy="3657600"/>
-          </a:xfrm>
-          <a:prstGeom prst="rect">
-            <a:avLst/>
-          </a:prstGeom>
-          <a:solidFill>
-            <a:srgbClr val="2E7D32"/>
-          </a:solidFill>
-          <a:ln>
-            <a:noFill/>
-          </a:ln>
-        </p:spPr>
-        <p:style>
-          <a:lnRef idx="1">
-            <a:schemeClr val="accent1"/>
-          </a:lnRef>
-          <a:fillRef idx="3">
-            <a:schemeClr val="accent1"/>
-          </a:fillRef>
-          <a:effectRef idx="2">
-            <a:schemeClr val="accent1"/>
-          </a:effectRef>
-          <a:fontRef idx="minor">
-            <a:schemeClr val="lt1"/>
-          </a:fontRef>
-        </p:style>
-        <p:txBody>
-          <a:bodyPr rtlCol="0" anchor="ctr"/>
-          <a:lstStyle/>
-          <a:p>
-            <a:pPr algn="ctr"/>
-          </a:p>
-        </p:txBody>
-      </p:sp>
-      <p:sp>
-        <p:nvSpPr>
-          <p:cNvPr id="18" name="TextBox 17"/>
-          <p:cNvSpPr txBox="1"/>
-          <p:nvPr/>
-        </p:nvSpPr>
-        <p:spPr>
-          <a:xfrm>
-            <a:off x="5376672" y="1389888"/>
-            <a:ext cx="2103120" cy="594360"/>
-          </a:xfrm>
-          <a:prstGeom prst="rect">
-            <a:avLst/>
-          </a:prstGeom>
-          <a:noFill/>
-        </p:spPr>
-        <p:txBody>
-          <a:bodyPr wrap="square">
-            <a:spAutoFit/>
-          </a:bodyPr>
-          <a:lstStyle/>
-          <a:p>
-            <a:pPr algn="ctr"/>
-            <a:r>
-              <a:rPr sz="2800" b="1" i="0">
-                <a:solidFill>
-                  <a:srgbClr val="FFFFFF"/>
-                </a:solidFill>
-                <a:latin typeface="Arial"/>
-              </a:rPr>
-              <a:t>h₃</a:t>
-            </a:r>
-          </a:p>
-        </p:txBody>
-      </p:sp>
-      <p:sp>
-        <p:nvSpPr>
-          <p:cNvPr id="19" name="TextBox 18"/>
-          <p:cNvSpPr txBox="1"/>
-          <p:nvPr/>
-        </p:nvSpPr>
-        <p:spPr>
-          <a:xfrm>
-            <a:off x="5376672" y="1984248"/>
-            <a:ext cx="2103120" cy="411480"/>
-          </a:xfrm>
-          <a:prstGeom prst="rect">
-            <a:avLst/>
-          </a:prstGeom>
-          <a:noFill/>
-        </p:spPr>
-        <p:txBody>
-          <a:bodyPr wrap="square">
-            <a:spAutoFit/>
-          </a:bodyPr>
-          <a:lstStyle/>
-          <a:p>
-            <a:pPr algn="ctr"/>
-            <a:r>
-              <a:rPr sz="1700" b="1" i="0">
-                <a:solidFill>
-                  <a:srgbClr val="FFFFFF"/>
-                </a:solidFill>
-                <a:latin typeface="Arial"/>
-              </a:rPr>
-              <a:t>Chain + Venue</a:t>
-            </a:r>
-          </a:p>
-        </p:txBody>
-      </p:sp>
-      <p:sp>
-        <p:nvSpPr>
-          <p:cNvPr id="20" name="TextBox 19"/>
-          <p:cNvSpPr txBox="1"/>
-          <p:nvPr/>
-        </p:nvSpPr>
-        <p:spPr>
-          <a:xfrm>
-            <a:off x="5376672" y="2414016"/>
-            <a:ext cx="2103120" cy="1188720"/>
-          </a:xfrm>
-          <a:prstGeom prst="rect">
-            <a:avLst/>
-          </a:prstGeom>
-          <a:noFill/>
-        </p:spPr>
-        <p:txBody>
-          <a:bodyPr wrap="square">
-            <a:spAutoFit/>
-          </a:bodyPr>
-          <a:lstStyle/>
-          <a:p>
-            <a:pPr algn="ctr"/>
-            <a:r>
-              <a:rPr sz="1200" b="0" i="0">
-                <a:solidFill>
-                  <a:srgbClr val="FFFFFF"/>
-                </a:solidFill>
-                <a:latin typeface="Courier New"/>
-              </a:rPr>
-              <a:t>On-chain settlement
-time penalty + venue
-reliability discount</a:t>
-            </a:r>
-          </a:p>
-        </p:txBody>
-      </p:sp>
-      <p:sp>
-        <p:nvSpPr>
-          <p:cNvPr id="21" name="TextBox 20"/>
-          <p:cNvSpPr txBox="1"/>
-          <p:nvPr/>
-        </p:nvSpPr>
-        <p:spPr>
-          <a:xfrm>
-            <a:off x="5376672" y="3767328"/>
-            <a:ext cx="2103120" cy="777240"/>
-          </a:xfrm>
-          <a:prstGeom prst="rect">
-            <a:avLst/>
-          </a:prstGeom>
-          <a:noFill/>
-        </p:spPr>
-        <p:txBody>
-          <a:bodyPr wrap="square">
-            <a:spAutoFit/>
-          </a:bodyPr>
-          <a:lstStyle/>
-          <a:p>
-            <a:pPr algn="ctr"/>
-            <a:r>
-              <a:rPr sz="1300" b="0" i="1">
-                <a:solidFill>
-                  <a:srgbClr val="FFFFAA"/>
-                </a:solidFill>
-                <a:latin typeface="Arial"/>
-              </a:rPr>
-              <a:t>"Will it settle
-in time?"</a:t>
-            </a:r>
-          </a:p>
-        </p:txBody>
-      </p:sp>
-      <p:sp>
-        <p:nvSpPr>
-          <p:cNvPr id="22" name="TextBox 21"/>
-          <p:cNvSpPr txBox="1"/>
-          <p:nvPr/>
-        </p:nvSpPr>
-        <p:spPr>
-          <a:xfrm>
-            <a:off x="7754112" y="1298448"/>
-            <a:ext cx="4090111" cy="320040"/>
-          </a:xfrm>
-          <a:prstGeom prst="rect">
-            <a:avLst/>
-          </a:prstGeom>
-          <a:noFill/>
-        </p:spPr>
-        <p:txBody>
-          <a:bodyPr wrap="square">
-            <a:spAutoFit/>
-          </a:bodyPr>
-          <a:lstStyle/>
-          <a:p>
-            <a:pPr algn="l"/>
-            <a:r>
-              <a:rPr sz="1400" b="1" i="0">
-                <a:solidFill>
-                  <a:srgbClr val="CC0633"/>
-                </a:solidFill>
-                <a:latin typeface="Arial"/>
-              </a:rPr>
-              <a:t>h₂ in detail:</a:t>
             </a:r>
           </a:p>
         </p:txBody>
       </p:sp>
       <p:pic>
         <p:nvPicPr>
-          <p:cNvPr id="23" name="Picture 22" descr="fin_slippage.png"/>
+          <p:cNvPr id="10" name="Picture 9" descr="fin_eq_h1.png"/>
           <p:cNvPicPr>
             <a:picLocks noChangeAspect="1"/>
           </p:cNvPicPr>
@@ -6980,7 +6500,556 @@
         </p:blipFill>
         <p:spPr>
           <a:xfrm>
-            <a:off x="7754112" y="1664208"/>
+            <a:off x="393192" y="2331720"/>
+            <a:ext cx="2194560" cy="952246"/>
+          </a:xfrm>
+          <a:prstGeom prst="rect">
+            <a:avLst/>
+          </a:prstGeom>
+        </p:spPr>
+      </p:pic>
+      <p:sp>
+        <p:nvSpPr>
+          <p:cNvPr id="11" name="TextBox 10"/>
+          <p:cNvSpPr txBox="1"/>
+          <p:nvPr/>
+        </p:nvSpPr>
+        <p:spPr>
+          <a:xfrm>
+            <a:off x="438912" y="3657600"/>
+            <a:ext cx="2103120" cy="640080"/>
+          </a:xfrm>
+          <a:prstGeom prst="rect">
+            <a:avLst/>
+          </a:prstGeom>
+          <a:noFill/>
+        </p:spPr>
+        <p:txBody>
+          <a:bodyPr wrap="square">
+            <a:spAutoFit/>
+          </a:bodyPr>
+          <a:lstStyle/>
+          <a:p>
+            <a:pPr algn="ctr"/>
+            <a:r>
+              <a:rPr sz="1200" b="0" i="1">
+                <a:solidFill>
+                  <a:srgbClr val="FFFFFF"/>
+                </a:solidFill>
+                <a:latin typeface="Arial"/>
+              </a:rPr>
+              <a:t>24h-volume scaled to
+order size and time</a:t>
+            </a:r>
+          </a:p>
+        </p:txBody>
+      </p:sp>
+      <p:sp>
+        <p:nvSpPr>
+          <p:cNvPr id="12" name="TextBox 11"/>
+          <p:cNvSpPr txBox="1"/>
+          <p:nvPr/>
+        </p:nvSpPr>
+        <p:spPr>
+          <a:xfrm>
+            <a:off x="438912" y="4343400"/>
+            <a:ext cx="2103120" cy="640080"/>
+          </a:xfrm>
+          <a:prstGeom prst="rect">
+            <a:avLst/>
+          </a:prstGeom>
+          <a:noFill/>
+        </p:spPr>
+        <p:txBody>
+          <a:bodyPr wrap="square">
+            <a:spAutoFit/>
+          </a:bodyPr>
+          <a:lstStyle/>
+          <a:p>
+            <a:pPr algn="ctr"/>
+            <a:r>
+              <a:rPr sz="1300" b="0" i="1">
+                <a:solidFill>
+                  <a:srgbClr val="FFFFAA"/>
+                </a:solidFill>
+                <a:latin typeface="Arial"/>
+              </a:rPr>
+              <a:t>"Can the book
+absorb our size?"</a:t>
+            </a:r>
+          </a:p>
+        </p:txBody>
+      </p:sp>
+      <p:sp>
+        <p:nvSpPr>
+          <p:cNvPr id="13" name="Rectangle 12"/>
+          <p:cNvSpPr/>
+          <p:nvPr/>
+        </p:nvSpPr>
+        <p:spPr>
+          <a:xfrm>
+            <a:off x="2816352" y="1234440"/>
+            <a:ext cx="2286000" cy="3840480"/>
+          </a:xfrm>
+          <a:prstGeom prst="rect">
+            <a:avLst/>
+          </a:prstGeom>
+          <a:solidFill>
+            <a:srgbClr val="CC0633"/>
+          </a:solidFill>
+          <a:ln>
+            <a:noFill/>
+          </a:ln>
+        </p:spPr>
+        <p:style>
+          <a:lnRef idx="1">
+            <a:schemeClr val="accent1"/>
+          </a:lnRef>
+          <a:fillRef idx="3">
+            <a:schemeClr val="accent1"/>
+          </a:fillRef>
+          <a:effectRef idx="2">
+            <a:schemeClr val="accent1"/>
+          </a:effectRef>
+          <a:fontRef idx="minor">
+            <a:schemeClr val="lt1"/>
+          </a:fontRef>
+        </p:style>
+        <p:txBody>
+          <a:bodyPr rtlCol="0" anchor="ctr"/>
+          <a:lstStyle/>
+          <a:p>
+            <a:pPr algn="ctr"/>
+          </a:p>
+        </p:txBody>
+      </p:sp>
+      <p:sp>
+        <p:nvSpPr>
+          <p:cNvPr id="14" name="TextBox 13"/>
+          <p:cNvSpPr txBox="1"/>
+          <p:nvPr/>
+        </p:nvSpPr>
+        <p:spPr>
+          <a:xfrm>
+            <a:off x="2907792" y="1325880"/>
+            <a:ext cx="2103120" cy="548640"/>
+          </a:xfrm>
+          <a:prstGeom prst="rect">
+            <a:avLst/>
+          </a:prstGeom>
+          <a:noFill/>
+        </p:spPr>
+        <p:txBody>
+          <a:bodyPr wrap="square">
+            <a:spAutoFit/>
+          </a:bodyPr>
+          <a:lstStyle/>
+          <a:p>
+            <a:pPr algn="ctr"/>
+            <a:r>
+              <a:rPr sz="2600" b="1" i="0">
+                <a:solidFill>
+                  <a:srgbClr val="FFFFFF"/>
+                </a:solidFill>
+                <a:latin typeface="Arial"/>
+              </a:rPr>
+              <a:t>h₂ ★</a:t>
+            </a:r>
+          </a:p>
+        </p:txBody>
+      </p:sp>
+      <p:sp>
+        <p:nvSpPr>
+          <p:cNvPr id="15" name="TextBox 14"/>
+          <p:cNvSpPr txBox="1"/>
+          <p:nvPr/>
+        </p:nvSpPr>
+        <p:spPr>
+          <a:xfrm>
+            <a:off x="2907792" y="1892808"/>
+            <a:ext cx="2103120" cy="365760"/>
+          </a:xfrm>
+          <a:prstGeom prst="rect">
+            <a:avLst/>
+          </a:prstGeom>
+          <a:noFill/>
+        </p:spPr>
+        <p:txBody>
+          <a:bodyPr wrap="square">
+            <a:spAutoFit/>
+          </a:bodyPr>
+          <a:lstStyle/>
+          <a:p>
+            <a:pPr algn="ctr"/>
+            <a:r>
+              <a:rPr sz="1600" b="1" i="0">
+                <a:solidFill>
+                  <a:srgbClr val="FFFFFF"/>
+                </a:solidFill>
+                <a:latin typeface="Arial"/>
+              </a:rPr>
+              <a:t>Slippage</a:t>
+            </a:r>
+          </a:p>
+        </p:txBody>
+      </p:sp>
+      <p:pic>
+        <p:nvPicPr>
+          <p:cNvPr id="16" name="Picture 15" descr="fin_eq_h2.png"/>
+          <p:cNvPicPr>
+            <a:picLocks noChangeAspect="1"/>
+          </p:cNvPicPr>
+          <p:nvPr/>
+        </p:nvPicPr>
+        <p:blipFill>
+          <a:blip r:embed="rId4"/>
+          <a:stretch>
+            <a:fillRect/>
+          </a:stretch>
+        </p:blipFill>
+        <p:spPr>
+          <a:xfrm>
+            <a:off x="2862072" y="2331720"/>
+            <a:ext cx="2194560" cy="1016000"/>
+          </a:xfrm>
+          <a:prstGeom prst="rect">
+            <a:avLst/>
+          </a:prstGeom>
+        </p:spPr>
+      </p:pic>
+      <p:sp>
+        <p:nvSpPr>
+          <p:cNvPr id="17" name="TextBox 16"/>
+          <p:cNvSpPr txBox="1"/>
+          <p:nvPr/>
+        </p:nvSpPr>
+        <p:spPr>
+          <a:xfrm>
+            <a:off x="2907792" y="3657600"/>
+            <a:ext cx="2103120" cy="640080"/>
+          </a:xfrm>
+          <a:prstGeom prst="rect">
+            <a:avLst/>
+          </a:prstGeom>
+          <a:noFill/>
+        </p:spPr>
+        <p:txBody>
+          <a:bodyPr wrap="square">
+            <a:spAutoFit/>
+          </a:bodyPr>
+          <a:lstStyle/>
+          <a:p>
+            <a:pPr algn="ctr"/>
+            <a:r>
+              <a:rPr sz="1200" b="0" i="1">
+                <a:solidFill>
+                  <a:srgbClr val="FFFFFF"/>
+                </a:solidFill>
+                <a:latin typeface="Arial"/>
+              </a:rPr>
+              <a:t>VWAP divergence from
+mid-quote, live L2</a:t>
+            </a:r>
+          </a:p>
+        </p:txBody>
+      </p:sp>
+      <p:sp>
+        <p:nvSpPr>
+          <p:cNvPr id="18" name="TextBox 17"/>
+          <p:cNvSpPr txBox="1"/>
+          <p:nvPr/>
+        </p:nvSpPr>
+        <p:spPr>
+          <a:xfrm>
+            <a:off x="2907792" y="4343400"/>
+            <a:ext cx="2103120" cy="640080"/>
+          </a:xfrm>
+          <a:prstGeom prst="rect">
+            <a:avLst/>
+          </a:prstGeom>
+          <a:noFill/>
+        </p:spPr>
+        <p:txBody>
+          <a:bodyPr wrap="square">
+            <a:spAutoFit/>
+          </a:bodyPr>
+          <a:lstStyle/>
+          <a:p>
+            <a:pPr algn="ctr"/>
+            <a:r>
+              <a:rPr sz="1300" b="0" i="1">
+                <a:solidFill>
+                  <a:srgbClr val="FFFFAA"/>
+                </a:solidFill>
+                <a:latin typeface="Arial"/>
+              </a:rPr>
+              <a:t>"Will my order
+move the price?"</a:t>
+            </a:r>
+          </a:p>
+        </p:txBody>
+      </p:sp>
+      <p:sp>
+        <p:nvSpPr>
+          <p:cNvPr id="19" name="Rectangle 18"/>
+          <p:cNvSpPr/>
+          <p:nvPr/>
+        </p:nvSpPr>
+        <p:spPr>
+          <a:xfrm>
+            <a:off x="5285232" y="1234440"/>
+            <a:ext cx="2286000" cy="3840480"/>
+          </a:xfrm>
+          <a:prstGeom prst="rect">
+            <a:avLst/>
+          </a:prstGeom>
+          <a:solidFill>
+            <a:srgbClr val="2E7D32"/>
+          </a:solidFill>
+          <a:ln>
+            <a:noFill/>
+          </a:ln>
+        </p:spPr>
+        <p:style>
+          <a:lnRef idx="1">
+            <a:schemeClr val="accent1"/>
+          </a:lnRef>
+          <a:fillRef idx="3">
+            <a:schemeClr val="accent1"/>
+          </a:fillRef>
+          <a:effectRef idx="2">
+            <a:schemeClr val="accent1"/>
+          </a:effectRef>
+          <a:fontRef idx="minor">
+            <a:schemeClr val="lt1"/>
+          </a:fontRef>
+        </p:style>
+        <p:txBody>
+          <a:bodyPr rtlCol="0" anchor="ctr"/>
+          <a:lstStyle/>
+          <a:p>
+            <a:pPr algn="ctr"/>
+          </a:p>
+        </p:txBody>
+      </p:sp>
+      <p:sp>
+        <p:nvSpPr>
+          <p:cNvPr id="20" name="TextBox 19"/>
+          <p:cNvSpPr txBox="1"/>
+          <p:nvPr/>
+        </p:nvSpPr>
+        <p:spPr>
+          <a:xfrm>
+            <a:off x="5376672" y="1325880"/>
+            <a:ext cx="2103120" cy="548640"/>
+          </a:xfrm>
+          <a:prstGeom prst="rect">
+            <a:avLst/>
+          </a:prstGeom>
+          <a:noFill/>
+        </p:spPr>
+        <p:txBody>
+          <a:bodyPr wrap="square">
+            <a:spAutoFit/>
+          </a:bodyPr>
+          <a:lstStyle/>
+          <a:p>
+            <a:pPr algn="ctr"/>
+            <a:r>
+              <a:rPr sz="2600" b="1" i="0">
+                <a:solidFill>
+                  <a:srgbClr val="FFFFFF"/>
+                </a:solidFill>
+                <a:latin typeface="Arial"/>
+              </a:rPr>
+              <a:t>h₃</a:t>
+            </a:r>
+          </a:p>
+        </p:txBody>
+      </p:sp>
+      <p:sp>
+        <p:nvSpPr>
+          <p:cNvPr id="21" name="TextBox 20"/>
+          <p:cNvSpPr txBox="1"/>
+          <p:nvPr/>
+        </p:nvSpPr>
+        <p:spPr>
+          <a:xfrm>
+            <a:off x="5376672" y="1892808"/>
+            <a:ext cx="2103120" cy="365760"/>
+          </a:xfrm>
+          <a:prstGeom prst="rect">
+            <a:avLst/>
+          </a:prstGeom>
+          <a:noFill/>
+        </p:spPr>
+        <p:txBody>
+          <a:bodyPr wrap="square">
+            <a:spAutoFit/>
+          </a:bodyPr>
+          <a:lstStyle/>
+          <a:p>
+            <a:pPr algn="ctr"/>
+            <a:r>
+              <a:rPr sz="1600" b="1" i="0">
+                <a:solidFill>
+                  <a:srgbClr val="FFFFFF"/>
+                </a:solidFill>
+                <a:latin typeface="Arial"/>
+              </a:rPr>
+              <a:t>Chain + Venue</a:t>
+            </a:r>
+          </a:p>
+        </p:txBody>
+      </p:sp>
+      <p:pic>
+        <p:nvPicPr>
+          <p:cNvPr id="22" name="Picture 21" descr="fin_eq_h3.png"/>
+          <p:cNvPicPr>
+            <a:picLocks noChangeAspect="1"/>
+          </p:cNvPicPr>
+          <p:nvPr/>
+        </p:nvPicPr>
+        <p:blipFill>
+          <a:blip r:embed="rId5"/>
+          <a:stretch>
+            <a:fillRect/>
+          </a:stretch>
+        </p:blipFill>
+        <p:spPr>
+          <a:xfrm>
+            <a:off x="5330952" y="2331720"/>
+            <a:ext cx="2194560" cy="1109226"/>
+          </a:xfrm>
+          <a:prstGeom prst="rect">
+            <a:avLst/>
+          </a:prstGeom>
+        </p:spPr>
+      </p:pic>
+      <p:sp>
+        <p:nvSpPr>
+          <p:cNvPr id="23" name="TextBox 22"/>
+          <p:cNvSpPr txBox="1"/>
+          <p:nvPr/>
+        </p:nvSpPr>
+        <p:spPr>
+          <a:xfrm>
+            <a:off x="5376672" y="3657600"/>
+            <a:ext cx="2103120" cy="640080"/>
+          </a:xfrm>
+          <a:prstGeom prst="rect">
+            <a:avLst/>
+          </a:prstGeom>
+          <a:noFill/>
+        </p:spPr>
+        <p:txBody>
+          <a:bodyPr wrap="square">
+            <a:spAutoFit/>
+          </a:bodyPr>
+          <a:lstStyle/>
+          <a:p>
+            <a:pPr algn="ctr"/>
+            <a:r>
+              <a:rPr sz="1200" b="0" i="1">
+                <a:solidFill>
+                  <a:srgbClr val="FFFFFF"/>
+                </a:solidFill>
+                <a:latin typeface="Arial"/>
+              </a:rPr>
+              <a:t>On-chain settlement
++ venue reliability</a:t>
+            </a:r>
+          </a:p>
+        </p:txBody>
+      </p:sp>
+      <p:sp>
+        <p:nvSpPr>
+          <p:cNvPr id="24" name="TextBox 23"/>
+          <p:cNvSpPr txBox="1"/>
+          <p:nvPr/>
+        </p:nvSpPr>
+        <p:spPr>
+          <a:xfrm>
+            <a:off x="5376672" y="4343400"/>
+            <a:ext cx="2103120" cy="640080"/>
+          </a:xfrm>
+          <a:prstGeom prst="rect">
+            <a:avLst/>
+          </a:prstGeom>
+          <a:noFill/>
+        </p:spPr>
+        <p:txBody>
+          <a:bodyPr wrap="square">
+            <a:spAutoFit/>
+          </a:bodyPr>
+          <a:lstStyle/>
+          <a:p>
+            <a:pPr algn="ctr"/>
+            <a:r>
+              <a:rPr sz="1300" b="0" i="1">
+                <a:solidFill>
+                  <a:srgbClr val="FFFFAA"/>
+                </a:solidFill>
+                <a:latin typeface="Arial"/>
+              </a:rPr>
+              <a:t>"Will it settle
+in time?"</a:t>
+            </a:r>
+          </a:p>
+        </p:txBody>
+      </p:sp>
+      <p:sp>
+        <p:nvSpPr>
+          <p:cNvPr id="25" name="TextBox 24"/>
+          <p:cNvSpPr txBox="1"/>
+          <p:nvPr/>
+        </p:nvSpPr>
+        <p:spPr>
+          <a:xfrm>
+            <a:off x="7754112" y="1234440"/>
+            <a:ext cx="4090111" cy="320040"/>
+          </a:xfrm>
+          <a:prstGeom prst="rect">
+            <a:avLst/>
+          </a:prstGeom>
+          <a:noFill/>
+        </p:spPr>
+        <p:txBody>
+          <a:bodyPr wrap="square">
+            <a:spAutoFit/>
+          </a:bodyPr>
+          <a:lstStyle/>
+          <a:p>
+            <a:pPr algn="l"/>
+            <a:r>
+              <a:rPr sz="1400" b="1" i="0">
+                <a:solidFill>
+                  <a:srgbClr val="CC0633"/>
+                </a:solidFill>
+                <a:latin typeface="Arial"/>
+              </a:rPr>
+              <a:t>h₂ in detail:</a:t>
+            </a:r>
+          </a:p>
+        </p:txBody>
+      </p:sp>
+      <p:pic>
+        <p:nvPicPr>
+          <p:cNvPr id="26" name="Picture 25" descr="fin_slippage.png"/>
+          <p:cNvPicPr>
+            <a:picLocks noChangeAspect="1"/>
+          </p:cNvPicPr>
+          <p:nvPr/>
+        </p:nvPicPr>
+        <p:blipFill>
+          <a:blip r:embed="rId6"/>
+          <a:stretch>
+            <a:fillRect/>
+          </a:stretch>
+        </p:blipFill>
+        <p:spPr>
+          <a:xfrm>
+            <a:off x="7754112" y="1600200"/>
             <a:ext cx="3998671" cy="2849769"/>
           </a:xfrm>
           <a:prstGeom prst="rect">
@@ -6990,14 +7059,14 @@
       </p:pic>
       <p:sp>
         <p:nvSpPr>
-          <p:cNvPr id="24" name="TextBox 23"/>
-          <p:cNvSpPr txBox="1"/>
-          <p:nvPr/>
-        </p:nvSpPr>
-        <p:spPr>
-          <a:xfrm>
-            <a:off x="347472" y="5120640"/>
-            <a:ext cx="11496751" cy="365760"/>
+          <p:cNvPr id="27" name="TextBox 26"/>
+          <p:cNvSpPr txBox="1"/>
+          <p:nvPr/>
+        </p:nvSpPr>
+        <p:spPr>
+          <a:xfrm>
+            <a:off x="347472" y="5166360"/>
+            <a:ext cx="11496751" cy="274320"/>
           </a:xfrm>
           <a:prstGeom prst="rect">
             <a:avLst/>
@@ -7012,7 +7081,42 @@
           <a:p>
             <a:pPr algn="ctr"/>
             <a:r>
-              <a:rPr sz="1600" b="1" i="1">
+              <a:rPr sz="1000" b="0" i="1">
+                <a:solidFill>
+                  <a:srgbClr val="888888"/>
+                </a:solidFill>
+                <a:latin typeface="Arial"/>
+              </a:rPr>
+              <a:t>Paper notation: h₃ here = h₄ in paper §4.4.  h₃ in the paper is the multi-start search strategy (§4.3).</a:t>
+            </a:r>
+          </a:p>
+        </p:txBody>
+      </p:sp>
+      <p:sp>
+        <p:nvSpPr>
+          <p:cNvPr id="28" name="TextBox 27"/>
+          <p:cNvSpPr txBox="1"/>
+          <p:nvPr/>
+        </p:nvSpPr>
+        <p:spPr>
+          <a:xfrm>
+            <a:off x="347472" y="5458968"/>
+            <a:ext cx="11496751" cy="320040"/>
+          </a:xfrm>
+          <a:prstGeom prst="rect">
+            <a:avLst/>
+          </a:prstGeom>
+          <a:noFill/>
+        </p:spPr>
+        <p:txBody>
+          <a:bodyPr wrap="square">
+            <a:spAutoFit/>
+          </a:bodyPr>
+          <a:lstStyle/>
+          <a:p>
+            <a:pPr algn="ctr"/>
+            <a:r>
+              <a:rPr sz="1500" b="1" i="1">
                 <a:solidFill>
                   <a:srgbClr val="CC0633"/>
                 </a:solidFill>
@@ -7025,7 +7129,7 @@
       </p:sp>
       <p:sp>
         <p:nvSpPr>
-          <p:cNvPr id="25" name="Rectangle 24"/>
+          <p:cNvPr id="29" name="Rectangle 28"/>
           <p:cNvSpPr/>
           <p:nvPr/>
         </p:nvSpPr>
@@ -7068,7 +7172,7 @@
       </p:sp>
       <p:sp>
         <p:nvSpPr>
-          <p:cNvPr id="26" name="TextBox 25"/>
+          <p:cNvPr id="30" name="TextBox 29"/>
           <p:cNvSpPr txBox="1"/>
           <p:nvPr/>
         </p:nvSpPr>
@@ -7103,7 +7207,7 @@
       </p:sp>
       <p:sp>
         <p:nvSpPr>
-          <p:cNvPr id="27" name="TextBox 26"/>
+          <p:cNvPr id="31" name="TextBox 30"/>
           <p:cNvSpPr txBox="1"/>
           <p:nvPr/>
         </p:nvSpPr>
@@ -7138,7 +7242,7 @@
       </p:sp>
       <p:sp>
         <p:nvSpPr>
-          <p:cNvPr id="28" name="TextBox 27"/>
+          <p:cNvPr id="32" name="TextBox 31"/>
           <p:cNvSpPr txBox="1"/>
           <p:nvPr/>
         </p:nvSpPr>

</xml_diff>